<commit_message>
Polish AURA capstone portfolio (#1)
Prepare the Microsoft × UC Irvine Dean's Favorite capstone for public portfolio review with a polished README, runnable dry-run example, tests, environment-safe configuration, and updated presentation artifacts.
</commit_message>
<xml_diff>
--- a/AURA_Agentic_Framework_Yunbo.pptx
+++ b/AURA_Agentic_Framework_Yunbo.pptx
@@ -6092,7 +6092,7 @@
         <p:spPr>
           <a:xfrm>
             <a:off x="777240" y="960120"/>
-            <a:ext cx="5623560" cy="2358452"/>
+            <a:ext cx="5623560" cy="3024098"/>
           </a:xfrm>
           <a:prstGeom prst="rect">
             <a:avLst/>
@@ -6611,7 +6611,7 @@
         <p:spPr>
           <a:xfrm>
             <a:off x="731520" y="960120"/>
-            <a:ext cx="10881360" cy="4993767"/>
+            <a:ext cx="10881360" cy="5285232"/>
           </a:xfrm>
           <a:prstGeom prst="rect">
             <a:avLst/>
@@ -9148,44 +9148,9 @@
         <p:nvPr/>
       </p:nvGrpSpPr>
       <p:grpSpPr/>
-      <p:sp>
-        <p:nvSpPr>
-          <p:cNvPr id="2" name="TextBox 1"/>
-          <p:cNvSpPr txBox="1"/>
-          <p:nvPr/>
-        </p:nvSpPr>
-        <p:spPr>
-          <a:xfrm>
-            <a:off x="713232" y="301752"/>
-            <a:ext cx="10789920" cy="530352"/>
-          </a:xfrm>
-          <a:prstGeom prst="rect">
-            <a:avLst/>
-          </a:prstGeom>
-          <a:noFill/>
-        </p:spPr>
-        <p:txBody>
-          <a:bodyPr wrap="none">
-            <a:spAutoFit/>
-          </a:bodyPr>
-          <a:lstStyle/>
-          <a:p>
-            <a:pPr>
-              <a:defRPr sz="3000">
-                <a:solidFill>
-                  <a:srgbClr val="000000"/>
-                </a:solidFill>
-              </a:defRPr>
-            </a:pPr>
-            <a:r>
-              <a:t>3 Stage Agent Flow</a:t>
-            </a:r>
-          </a:p>
-        </p:txBody>
-      </p:sp>
       <p:pic>
         <p:nvPicPr>
-          <p:cNvPr id="3" name="Picture 2" descr="agent_Flow.png"/>
+          <p:cNvPr id="2" name="Picture 1" descr="agent_flow.png"/>
           <p:cNvPicPr>
             <a:picLocks noChangeAspect="1"/>
           </p:cNvPicPr>
@@ -9199,8 +9164,8 @@
         </p:blipFill>
         <p:spPr>
           <a:xfrm>
-            <a:off x="228600" y="932688"/>
-            <a:ext cx="11750040" cy="5931151"/>
+            <a:off x="713232" y="109728"/>
+            <a:ext cx="10771632" cy="5991164"/>
           </a:xfrm>
           <a:prstGeom prst="rect">
             <a:avLst/>
@@ -9209,7 +9174,7 @@
       </p:pic>
       <p:sp>
         <p:nvSpPr>
-          <p:cNvPr id="4" name="Rectangle 3"/>
+          <p:cNvPr id="3" name="Rectangle 2"/>
           <p:cNvSpPr/>
           <p:nvPr/>
         </p:nvSpPr>
@@ -9252,7 +9217,7 @@
       </p:sp>
       <p:sp>
         <p:nvSpPr>
-          <p:cNvPr id="5" name="Rectangle 4"/>
+          <p:cNvPr id="4" name="Rectangle 3"/>
           <p:cNvSpPr/>
           <p:nvPr/>
         </p:nvSpPr>
@@ -9295,7 +9260,7 @@
       </p:sp>
       <p:sp>
         <p:nvSpPr>
-          <p:cNvPr id="6" name="Parallelogram 5"/>
+          <p:cNvPr id="5" name="Parallelogram 4"/>
           <p:cNvSpPr/>
           <p:nvPr/>
         </p:nvSpPr>
@@ -9338,7 +9303,7 @@
       </p:sp>
       <p:sp>
         <p:nvSpPr>
-          <p:cNvPr id="7" name="Parallelogram 6"/>
+          <p:cNvPr id="6" name="Parallelogram 5"/>
           <p:cNvSpPr/>
           <p:nvPr/>
         </p:nvSpPr>
@@ -9381,7 +9346,7 @@
       </p:sp>
       <p:sp>
         <p:nvSpPr>
-          <p:cNvPr id="8" name="Parallelogram 7"/>
+          <p:cNvPr id="7" name="Parallelogram 6"/>
           <p:cNvSpPr/>
           <p:nvPr/>
         </p:nvSpPr>
@@ -9424,7 +9389,7 @@
       </p:sp>
       <p:sp>
         <p:nvSpPr>
-          <p:cNvPr id="9" name="TextBox 8"/>
+          <p:cNvPr id="8" name="TextBox 7"/>
           <p:cNvSpPr txBox="1"/>
           <p:nvPr/>
         </p:nvSpPr>
@@ -9471,7 +9436,7 @@
       </p:sp>
       <p:sp>
         <p:nvSpPr>
-          <p:cNvPr id="10" name="TextBox 9"/>
+          <p:cNvPr id="9" name="TextBox 8"/>
           <p:cNvSpPr txBox="1"/>
           <p:nvPr/>
         </p:nvSpPr>
@@ -9506,7 +9471,7 @@
       </p:sp>
       <p:sp>
         <p:nvSpPr>
-          <p:cNvPr id="11" name="TextBox 10"/>
+          <p:cNvPr id="10" name="TextBox 9"/>
           <p:cNvSpPr txBox="1"/>
           <p:nvPr/>
         </p:nvSpPr>

</xml_diff>